<commit_message>
docs: align final-minute pitch with rubric
</commit_message>
<xml_diff>
--- a/deliverables/StudyCrew_Milestone_Presentation.pptx
+++ b/deliverables/StudyCrew_Milestone_Presentation.pptx
@@ -2,18 +2,18 @@
 <file path=ppt/presentation.xml><?xml version="1.0" encoding="utf-8"?>
 <p:presentation xmlns:p="http://schemas.openxmlformats.org/presentationml/2006/main">
   <p:sldMasterIdLst>
-    <p:sldMasterId xmlns:r="http://schemas.openxmlformats.org/officeDocument/2006/relationships" id="2147483648" r:id="R86dc61a88d814054"/>
+    <p:sldMasterId xmlns:r="http://schemas.openxmlformats.org/officeDocument/2006/relationships" id="2147483648" r:id="R2bb0890a3bab44d2"/>
   </p:sldMasterIdLst>
   <p:notesMasterIdLst>
-    <p:notesMasterId xmlns:r="http://schemas.openxmlformats.org/officeDocument/2006/relationships" r:id="Rc95f318b3e3a43f4"/>
+    <p:notesMasterId xmlns:r="http://schemas.openxmlformats.org/officeDocument/2006/relationships" r:id="Rf980805dc242475a"/>
   </p:notesMasterIdLst>
   <p:sldIdLst>
-    <p:sldId xmlns:r="http://schemas.openxmlformats.org/officeDocument/2006/relationships" id="256" r:id="R83adc34415e84b3e"/>
-    <p:sldId xmlns:r="http://schemas.openxmlformats.org/officeDocument/2006/relationships" id="257" r:id="R105d351432114409"/>
-    <p:sldId xmlns:r="http://schemas.openxmlformats.org/officeDocument/2006/relationships" id="258" r:id="Rdd6a498f12ba448c"/>
-    <p:sldId xmlns:r="http://schemas.openxmlformats.org/officeDocument/2006/relationships" id="259" r:id="R7196fb04ebf34e6c"/>
-    <p:sldId xmlns:r="http://schemas.openxmlformats.org/officeDocument/2006/relationships" id="260" r:id="R900cf94fc3aa4f61"/>
-    <p:sldId xmlns:r="http://schemas.openxmlformats.org/officeDocument/2006/relationships" id="261" r:id="R0a13c873756748c7"/>
+    <p:sldId xmlns:r="http://schemas.openxmlformats.org/officeDocument/2006/relationships" id="256" r:id="Rcaf2c6cf3f9641f7"/>
+    <p:sldId xmlns:r="http://schemas.openxmlformats.org/officeDocument/2006/relationships" id="257" r:id="R6be37eb5b1674b93"/>
+    <p:sldId xmlns:r="http://schemas.openxmlformats.org/officeDocument/2006/relationships" id="258" r:id="Rf16311fc159644fa"/>
+    <p:sldId xmlns:r="http://schemas.openxmlformats.org/officeDocument/2006/relationships" id="259" r:id="R004ac8ed25764721"/>
+    <p:sldId xmlns:r="http://schemas.openxmlformats.org/officeDocument/2006/relationships" id="260" r:id="R8c6232198aa04b6b"/>
+    <p:sldId xmlns:r="http://schemas.openxmlformats.org/officeDocument/2006/relationships" id="261" r:id="Rea54e7f9a34042cf"/>
   </p:sldIdLst>
   <p:sldSz cx="12192000" cy="6858000"/>
   <p:notesSz cx="6858000" cy="9144000"/>
@@ -962,7 +962,7 @@
           </a:p>
           <a:p xmlns:a="http://schemas.openxmlformats.org/drawingml/2006/main">
             <a:r>
-              <a:t>Our approved baseline is authentication, private projects, tasks, comments, meetings, notifications and contribution evidence. We build those from weeks 7 to 10, integrate and test in weeks 10 to 11, then rehearse and harden in week 12. Search and export remain stretch goals until the core passes.</a:t>
+              <a:t>Our approved baseline is authentication, private projects, tasks, comments, meetings, notifications and contribution evidence. We will build it with React and Express, PostgreSQL with Prisma, Vitest and Playwright, plus Docker and GitHub Actions. The Gantt moves from MVP validation into core vertical slices, integration and testing, then rehearsal and hardening. Search and export remain gated stretch goals.</a:t>
             </a:r>
           </a:p>
           <a:p xmlns:a="http://schemas.openxmlformats.org/drawingml/2006/main">
@@ -1075,7 +1075,7 @@
   </p:cSld>
   <p:clrMap bg1="lt1" tx1="dk1" bg2="lt2" tx2="dk2" accent1="accent1" accent2="accent2" accent3="accent3" accent4="accent4" accent5="accent5" accent6="accent6" hlink="hlink" folHlink="folHlink"/>
   <p:sldLayoutIdLst>
-    <p:sldLayoutId xmlns:r="http://schemas.openxmlformats.org/officeDocument/2006/relationships" id="2147483649" r:id="Rd661ae35cd4c4b80"/>
+    <p:sldLayoutId xmlns:r="http://schemas.openxmlformats.org/officeDocument/2006/relationships" id="2147483649" r:id="Rd8106d415e1645ac"/>
   </p:sldLayoutIdLst>
   <p:txStyles>
     <p:titleStyle>
@@ -1685,6 +1685,7 @@
           <a:lstStyle xmlns:a="http://schemas.openxmlformats.org/drawingml/2006/main"/>
           <a:p xmlns:a="http://schemas.openxmlformats.org/drawingml/2006/main">
             <a:pPr>
+              <a:buNone/>
               <a:defRPr sz="1275" b="1">
                 <a:solidFill>
                   <a:srgbClr val="BFE2D4"/>
@@ -1735,6 +1736,7 @@
           <a:lstStyle xmlns:a="http://schemas.openxmlformats.org/drawingml/2006/main"/>
           <a:p xmlns:a="http://schemas.openxmlformats.org/drawingml/2006/main">
             <a:pPr>
+              <a:buNone/>
               <a:defRPr sz="4650" b="1">
                 <a:solidFill>
                   <a:srgbClr val="FFFFFF"/>
@@ -1752,6 +1754,7 @@
           </a:p>
           <a:p xmlns:a="http://schemas.openxmlformats.org/drawingml/2006/main">
             <a:pPr>
+              <a:buNone/>
               <a:defRPr sz="4650" b="1">
                 <a:solidFill>
                   <a:srgbClr val="FFFFFF"/>
@@ -1769,6 +1772,7 @@
           </a:p>
           <a:p xmlns:a="http://schemas.openxmlformats.org/drawingml/2006/main">
             <a:pPr>
+              <a:buNone/>
               <a:defRPr sz="4650" b="1">
                 <a:solidFill>
                   <a:srgbClr val="FFFFFF"/>
@@ -1850,6 +1854,7 @@
           <a:lstStyle xmlns:a="http://schemas.openxmlformats.org/drawingml/2006/main"/>
           <a:p xmlns:a="http://schemas.openxmlformats.org/drawingml/2006/main">
             <a:pPr>
+              <a:buNone/>
               <a:defRPr sz="1800" b="0">
                 <a:solidFill>
                   <a:srgbClr val="D8E3EC"/>
@@ -1933,6 +1938,7 @@
           <a:lstStyle xmlns:a="http://schemas.openxmlformats.org/drawingml/2006/main"/>
           <a:p xmlns:a="http://schemas.openxmlformats.org/drawingml/2006/main">
             <a:pPr>
+              <a:buNone/>
               <a:defRPr sz="1800" b="1">
                 <a:solidFill>
                   <a:srgbClr val="FFFFFF"/>
@@ -1983,6 +1989,7 @@
           <a:lstStyle xmlns:a="http://schemas.openxmlformats.org/drawingml/2006/main"/>
           <a:p xmlns:a="http://schemas.openxmlformats.org/drawingml/2006/main">
             <a:pPr>
+              <a:buNone/>
               <a:defRPr sz="1800" b="1">
                 <a:solidFill>
                   <a:srgbClr val="FFFFFF"/>
@@ -2033,6 +2040,7 @@
           <a:lstStyle xmlns:a="http://schemas.openxmlformats.org/drawingml/2006/main"/>
           <a:p xmlns:a="http://schemas.openxmlformats.org/drawingml/2006/main">
             <a:pPr>
+              <a:buNone/>
               <a:defRPr sz="1800" b="1">
                 <a:solidFill>
                   <a:srgbClr val="FFFFFF"/>
@@ -2083,6 +2091,7 @@
           <a:lstStyle xmlns:a="http://schemas.openxmlformats.org/drawingml/2006/main"/>
           <a:p xmlns:a="http://schemas.openxmlformats.org/drawingml/2006/main">
             <a:pPr>
+              <a:buNone/>
               <a:defRPr sz="1200" b="0" i="1">
                 <a:solidFill>
                   <a:srgbClr val="BFE2D4"/>
@@ -2133,6 +2142,7 @@
           <a:lstStyle xmlns:a="http://schemas.openxmlformats.org/drawingml/2006/main"/>
           <a:p xmlns:a="http://schemas.openxmlformats.org/drawingml/2006/main">
             <a:pPr>
+              <a:buNone/>
               <a:defRPr sz="900" b="1">
                 <a:solidFill>
                   <a:srgbClr val="A8BAC9"/>
@@ -2212,6 +2222,7 @@
           <a:lstStyle xmlns:a="http://schemas.openxmlformats.org/drawingml/2006/main"/>
           <a:p xmlns:a="http://schemas.openxmlformats.org/drawingml/2006/main">
             <a:pPr>
+              <a:buNone/>
               <a:defRPr sz="1125" b="1">
                 <a:solidFill>
                   <a:srgbClr val="2774C7"/>
@@ -2262,6 +2273,7 @@
           <a:lstStyle xmlns:a="http://schemas.openxmlformats.org/drawingml/2006/main"/>
           <a:p xmlns:a="http://schemas.openxmlformats.org/drawingml/2006/main">
             <a:pPr>
+              <a:buNone/>
               <a:defRPr sz="3150" b="1">
                 <a:solidFill>
                   <a:srgbClr val="12263A"/>
@@ -2343,6 +2355,7 @@
           <a:lstStyle xmlns:a="http://schemas.openxmlformats.org/drawingml/2006/main"/>
           <a:p xmlns:a="http://schemas.openxmlformats.org/drawingml/2006/main">
             <a:pPr>
+              <a:buNone/>
               <a:defRPr sz="1275" b="0">
                 <a:solidFill>
                   <a:srgbClr val="667482"/>
@@ -2461,6 +2474,7 @@
           <a:lstStyle xmlns:a="http://schemas.openxmlformats.org/drawingml/2006/main"/>
           <a:p xmlns:a="http://schemas.openxmlformats.org/drawingml/2006/main">
             <a:pPr>
+              <a:buNone/>
               <a:defRPr sz="1050" b="1">
                 <a:solidFill>
                   <a:srgbClr val="2774C7"/>
@@ -2511,6 +2525,7 @@
           <a:lstStyle xmlns:a="http://schemas.openxmlformats.org/drawingml/2006/main"/>
           <a:p xmlns:a="http://schemas.openxmlformats.org/drawingml/2006/main">
             <a:pPr>
+              <a:buNone/>
               <a:defRPr sz="2400" b="1">
                 <a:solidFill>
                   <a:srgbClr val="12263A"/>
@@ -2528,6 +2543,7 @@
           </a:p>
           <a:p xmlns:a="http://schemas.openxmlformats.org/drawingml/2006/main">
             <a:pPr>
+              <a:buNone/>
               <a:defRPr sz="2400" b="1">
                 <a:solidFill>
                   <a:srgbClr val="12263A"/>
@@ -2545,6 +2561,7 @@
           </a:p>
           <a:p xmlns:a="http://schemas.openxmlformats.org/drawingml/2006/main">
             <a:pPr>
+              <a:buNone/>
               <a:defRPr sz="2400" b="1">
                 <a:solidFill>
                   <a:srgbClr val="12263A"/>
@@ -2595,6 +2612,7 @@
           <a:lstStyle xmlns:a="http://schemas.openxmlformats.org/drawingml/2006/main"/>
           <a:p xmlns:a="http://schemas.openxmlformats.org/drawingml/2006/main">
             <a:pPr>
+              <a:buNone/>
               <a:defRPr sz="1425" b="0">
                 <a:solidFill>
                   <a:srgbClr val="667482"/>
@@ -2645,6 +2663,7 @@
           <a:lstStyle xmlns:a="http://schemas.openxmlformats.org/drawingml/2006/main"/>
           <a:p xmlns:a="http://schemas.openxmlformats.org/drawingml/2006/main">
             <a:pPr>
+              <a:buNone/>
               <a:defRPr sz="1050" b="1">
                 <a:solidFill>
                   <a:srgbClr val="BFE2D4"/>
@@ -2695,6 +2714,7 @@
           <a:lstStyle xmlns:a="http://schemas.openxmlformats.org/drawingml/2006/main"/>
           <a:p xmlns:a="http://schemas.openxmlformats.org/drawingml/2006/main">
             <a:pPr>
+              <a:buNone/>
               <a:defRPr sz="2400" b="1">
                 <a:solidFill>
                   <a:srgbClr val="FFFFFF"/>
@@ -2712,6 +2732,7 @@
           </a:p>
           <a:p xmlns:a="http://schemas.openxmlformats.org/drawingml/2006/main">
             <a:pPr>
+              <a:buNone/>
               <a:defRPr sz="2400" b="1">
                 <a:solidFill>
                   <a:srgbClr val="FFFFFF"/>
@@ -2729,6 +2750,7 @@
           </a:p>
           <a:p xmlns:a="http://schemas.openxmlformats.org/drawingml/2006/main">
             <a:pPr>
+              <a:buNone/>
               <a:defRPr sz="2400" b="1">
                 <a:solidFill>
                   <a:srgbClr val="FFFFFF"/>
@@ -2779,6 +2801,7 @@
           <a:lstStyle xmlns:a="http://schemas.openxmlformats.org/drawingml/2006/main"/>
           <a:p xmlns:a="http://schemas.openxmlformats.org/drawingml/2006/main">
             <a:pPr>
+              <a:buNone/>
               <a:defRPr sz="1425" b="0">
                 <a:solidFill>
                   <a:srgbClr val="D8E3EC"/>
@@ -2862,6 +2885,7 @@
           <a:lstStyle xmlns:a="http://schemas.openxmlformats.org/drawingml/2006/main"/>
           <a:p xmlns:a="http://schemas.openxmlformats.org/drawingml/2006/main">
             <a:pPr>
+              <a:buNone/>
               <a:defRPr sz="975" b="1">
                 <a:solidFill>
                   <a:srgbClr val="FFFFFF"/>
@@ -2912,6 +2936,7 @@
           <a:lstStyle xmlns:a="http://schemas.openxmlformats.org/drawingml/2006/main"/>
           <a:p xmlns:a="http://schemas.openxmlformats.org/drawingml/2006/main">
             <a:pPr>
+              <a:buNone/>
               <a:defRPr sz="825" b="1">
                 <a:solidFill>
                   <a:srgbClr val="667482"/>
@@ -2962,6 +2987,7 @@
           <a:lstStyle xmlns:a="http://schemas.openxmlformats.org/drawingml/2006/main"/>
           <a:p xmlns:a="http://schemas.openxmlformats.org/drawingml/2006/main">
             <a:pPr>
+              <a:buNone/>
               <a:defRPr sz="825" b="1">
                 <a:solidFill>
                   <a:srgbClr val="667482"/>
@@ -3041,6 +3067,7 @@
           <a:lstStyle xmlns:a="http://schemas.openxmlformats.org/drawingml/2006/main"/>
           <a:p xmlns:a="http://schemas.openxmlformats.org/drawingml/2006/main">
             <a:pPr>
+              <a:buNone/>
               <a:defRPr sz="1125" b="1">
                 <a:solidFill>
                   <a:srgbClr val="2774C7"/>
@@ -3091,6 +3118,7 @@
           <a:lstStyle xmlns:a="http://schemas.openxmlformats.org/drawingml/2006/main"/>
           <a:p xmlns:a="http://schemas.openxmlformats.org/drawingml/2006/main">
             <a:pPr>
+              <a:buNone/>
               <a:defRPr sz="3150" b="1">
                 <a:solidFill>
                   <a:srgbClr val="12263A"/>
@@ -3172,6 +3200,7 @@
           <a:lstStyle xmlns:a="http://schemas.openxmlformats.org/drawingml/2006/main"/>
           <a:p xmlns:a="http://schemas.openxmlformats.org/drawingml/2006/main">
             <a:pPr>
+              <a:buNone/>
               <a:defRPr sz="1275" b="0">
                 <a:solidFill>
                   <a:srgbClr val="667482"/>
@@ -3257,6 +3286,7 @@
           <a:lstStyle xmlns:a="http://schemas.openxmlformats.org/drawingml/2006/main"/>
           <a:p xmlns:a="http://schemas.openxmlformats.org/drawingml/2006/main">
             <a:pPr>
+              <a:buNone/>
               <a:defRPr sz="1275" b="1">
                 <a:solidFill>
                   <a:srgbClr val="E96B4B"/>
@@ -3307,6 +3337,7 @@
           <a:lstStyle xmlns:a="http://schemas.openxmlformats.org/drawingml/2006/main"/>
           <a:p xmlns:a="http://schemas.openxmlformats.org/drawingml/2006/main">
             <a:pPr>
+              <a:buNone/>
               <a:defRPr sz="2025" b="1">
                 <a:solidFill>
                   <a:srgbClr val="12263A"/>
@@ -3357,6 +3388,7 @@
           <a:lstStyle xmlns:a="http://schemas.openxmlformats.org/drawingml/2006/main"/>
           <a:p xmlns:a="http://schemas.openxmlformats.org/drawingml/2006/main">
             <a:pPr>
+              <a:buNone/>
               <a:defRPr sz="1575" b="0">
                 <a:solidFill>
                   <a:srgbClr val="667482"/>
@@ -3374,6 +3406,7 @@
           </a:p>
           <a:p xmlns:a="http://schemas.openxmlformats.org/drawingml/2006/main">
             <a:pPr>
+              <a:buNone/>
               <a:defRPr sz="1575" b="0">
                 <a:solidFill>
                   <a:srgbClr val="667482"/>
@@ -3391,6 +3424,7 @@
           </a:p>
           <a:p xmlns:a="http://schemas.openxmlformats.org/drawingml/2006/main">
             <a:pPr>
+              <a:buNone/>
               <a:defRPr sz="1575" b="0">
                 <a:solidFill>
                   <a:srgbClr val="667482"/>
@@ -3476,6 +3510,7 @@
           <a:lstStyle xmlns:a="http://schemas.openxmlformats.org/drawingml/2006/main"/>
           <a:p xmlns:a="http://schemas.openxmlformats.org/drawingml/2006/main">
             <a:pPr>
+              <a:buNone/>
               <a:defRPr sz="1275" b="1">
                 <a:solidFill>
                   <a:srgbClr val="E96B4B"/>
@@ -3526,6 +3561,7 @@
           <a:lstStyle xmlns:a="http://schemas.openxmlformats.org/drawingml/2006/main"/>
           <a:p xmlns:a="http://schemas.openxmlformats.org/drawingml/2006/main">
             <a:pPr>
+              <a:buNone/>
               <a:defRPr sz="2025" b="1">
                 <a:solidFill>
                   <a:srgbClr val="12263A"/>
@@ -3576,6 +3612,7 @@
           <a:lstStyle xmlns:a="http://schemas.openxmlformats.org/drawingml/2006/main"/>
           <a:p xmlns:a="http://schemas.openxmlformats.org/drawingml/2006/main">
             <a:pPr>
+              <a:buNone/>
               <a:defRPr sz="1575" b="0">
                 <a:solidFill>
                   <a:srgbClr val="667482"/>
@@ -3593,6 +3630,7 @@
           </a:p>
           <a:p xmlns:a="http://schemas.openxmlformats.org/drawingml/2006/main">
             <a:pPr>
+              <a:buNone/>
               <a:defRPr sz="1575" b="0">
                 <a:solidFill>
                   <a:srgbClr val="667482"/>
@@ -3610,6 +3648,7 @@
           </a:p>
           <a:p xmlns:a="http://schemas.openxmlformats.org/drawingml/2006/main">
             <a:pPr>
+              <a:buNone/>
               <a:defRPr sz="1575" b="0">
                 <a:solidFill>
                   <a:srgbClr val="667482"/>
@@ -3695,6 +3734,7 @@
           <a:lstStyle xmlns:a="http://schemas.openxmlformats.org/drawingml/2006/main"/>
           <a:p xmlns:a="http://schemas.openxmlformats.org/drawingml/2006/main">
             <a:pPr>
+              <a:buNone/>
               <a:defRPr sz="1275" b="1">
                 <a:solidFill>
                   <a:srgbClr val="E96B4B"/>
@@ -3745,6 +3785,7 @@
           <a:lstStyle xmlns:a="http://schemas.openxmlformats.org/drawingml/2006/main"/>
           <a:p xmlns:a="http://schemas.openxmlformats.org/drawingml/2006/main">
             <a:pPr>
+              <a:buNone/>
               <a:defRPr sz="2025" b="1">
                 <a:solidFill>
                   <a:srgbClr val="12263A"/>
@@ -3795,6 +3836,7 @@
           <a:lstStyle xmlns:a="http://schemas.openxmlformats.org/drawingml/2006/main"/>
           <a:p xmlns:a="http://schemas.openxmlformats.org/drawingml/2006/main">
             <a:pPr>
+              <a:buNone/>
               <a:defRPr sz="1575" b="0">
                 <a:solidFill>
                   <a:srgbClr val="667482"/>
@@ -3812,6 +3854,7 @@
           </a:p>
           <a:p xmlns:a="http://schemas.openxmlformats.org/drawingml/2006/main">
             <a:pPr>
+              <a:buNone/>
               <a:defRPr sz="1575" b="0">
                 <a:solidFill>
                   <a:srgbClr val="667482"/>
@@ -3829,6 +3872,7 @@
           </a:p>
           <a:p xmlns:a="http://schemas.openxmlformats.org/drawingml/2006/main">
             <a:pPr>
+              <a:buNone/>
               <a:defRPr sz="1575" b="0">
                 <a:solidFill>
                   <a:srgbClr val="667482"/>
@@ -3879,6 +3923,7 @@
           <a:lstStyle xmlns:a="http://schemas.openxmlformats.org/drawingml/2006/main"/>
           <a:p xmlns:a="http://schemas.openxmlformats.org/drawingml/2006/main">
             <a:pPr>
+              <a:buNone/>
               <a:defRPr sz="2550" b="1">
                 <a:solidFill>
                   <a:srgbClr val="2774C7"/>
@@ -3929,6 +3974,7 @@
           <a:lstStyle xmlns:a="http://schemas.openxmlformats.org/drawingml/2006/main"/>
           <a:p xmlns:a="http://schemas.openxmlformats.org/drawingml/2006/main">
             <a:pPr>
+              <a:buNone/>
               <a:defRPr sz="2550" b="1">
                 <a:solidFill>
                   <a:srgbClr val="2774C7"/>
@@ -4012,6 +4058,7 @@
           <a:lstStyle xmlns:a="http://schemas.openxmlformats.org/drawingml/2006/main"/>
           <a:p xmlns:a="http://schemas.openxmlformats.org/drawingml/2006/main">
             <a:pPr>
+              <a:buNone/>
               <a:defRPr sz="1275" b="1">
                 <a:solidFill>
                   <a:srgbClr val="BFE2D4"/>
@@ -4062,6 +4109,7 @@
           <a:lstStyle xmlns:a="http://schemas.openxmlformats.org/drawingml/2006/main"/>
           <a:p xmlns:a="http://schemas.openxmlformats.org/drawingml/2006/main">
             <a:pPr>
+              <a:buNone/>
               <a:defRPr sz="1350" b="0" i="1">
                 <a:solidFill>
                   <a:srgbClr val="FFFFFF"/>
@@ -4112,6 +4160,7 @@
           <a:lstStyle xmlns:a="http://schemas.openxmlformats.org/drawingml/2006/main"/>
           <a:p xmlns:a="http://schemas.openxmlformats.org/drawingml/2006/main">
             <a:pPr>
+              <a:buNone/>
               <a:defRPr sz="825" b="1">
                 <a:solidFill>
                   <a:srgbClr val="667482"/>
@@ -4162,6 +4211,7 @@
           <a:lstStyle xmlns:a="http://schemas.openxmlformats.org/drawingml/2006/main"/>
           <a:p xmlns:a="http://schemas.openxmlformats.org/drawingml/2006/main">
             <a:pPr>
+              <a:buNone/>
               <a:defRPr sz="825" b="1">
                 <a:solidFill>
                   <a:srgbClr val="667482"/>
@@ -4241,6 +4291,7 @@
           <a:lstStyle xmlns:a="http://schemas.openxmlformats.org/drawingml/2006/main"/>
           <a:p xmlns:a="http://schemas.openxmlformats.org/drawingml/2006/main">
             <a:pPr>
+              <a:buNone/>
               <a:defRPr sz="1125" b="1">
                 <a:solidFill>
                   <a:srgbClr val="2774C7"/>
@@ -4291,6 +4342,7 @@
           <a:lstStyle xmlns:a="http://schemas.openxmlformats.org/drawingml/2006/main"/>
           <a:p xmlns:a="http://schemas.openxmlformats.org/drawingml/2006/main">
             <a:pPr>
+              <a:buNone/>
               <a:defRPr sz="3150" b="1">
                 <a:solidFill>
                   <a:srgbClr val="12263A"/>
@@ -4372,6 +4424,7 @@
           <a:lstStyle xmlns:a="http://schemas.openxmlformats.org/drawingml/2006/main"/>
           <a:p xmlns:a="http://schemas.openxmlformats.org/drawingml/2006/main">
             <a:pPr>
+              <a:buNone/>
               <a:defRPr sz="1275" b="0">
                 <a:solidFill>
                   <a:srgbClr val="667482"/>
@@ -4461,14 +4514,14 @@
       </p:sp>
       <p:pic>
         <p:nvPicPr>
-          <p:cNvPr id="21" name=""/>
+          <p:cNvPr id="24" name=""/>
           <p:cNvPicPr>
             <a:picLocks xmlns:a="http://schemas.openxmlformats.org/drawingml/2006/main" noChangeAspect="1"/>
           </p:cNvPicPr>
           <p:nvPr/>
         </p:nvPicPr>
         <p:blipFill>
-          <a:blip xmlns:r="http://schemas.openxmlformats.org/officeDocument/2006/relationships" xmlns:a="http://schemas.openxmlformats.org/drawingml/2006/main" r:embed="R37714002f2904851"/>
+          <a:blip xmlns:r="http://schemas.openxmlformats.org/officeDocument/2006/relationships" xmlns:a="http://schemas.openxmlformats.org/drawingml/2006/main" r:embed="R32d8ec87a39446d3"/>
           <a:stretch xmlns:a="http://schemas.openxmlformats.org/drawingml/2006/main"/>
         </p:blipFill>
         <p:spPr>
@@ -4483,14 +4536,14 @@
       </p:pic>
       <p:pic>
         <p:nvPicPr>
-          <p:cNvPr id="22" name=""/>
+          <p:cNvPr id="25" name=""/>
           <p:cNvPicPr>
             <a:picLocks xmlns:a="http://schemas.openxmlformats.org/drawingml/2006/main" noChangeAspect="1"/>
           </p:cNvPicPr>
           <p:nvPr/>
         </p:nvPicPr>
         <p:blipFill>
-          <a:blip xmlns:r="http://schemas.openxmlformats.org/officeDocument/2006/relationships" xmlns:a="http://schemas.openxmlformats.org/drawingml/2006/main" r:embed="R46852466eeac444b"/>
+          <a:blip xmlns:r="http://schemas.openxmlformats.org/officeDocument/2006/relationships" xmlns:a="http://schemas.openxmlformats.org/drawingml/2006/main" r:embed="R44f41d651fac48a6"/>
           <a:stretch xmlns:a="http://schemas.openxmlformats.org/drawingml/2006/main"/>
         </p:blipFill>
         <p:spPr>
@@ -4536,6 +4589,7 @@
           <a:lstStyle xmlns:a="http://schemas.openxmlformats.org/drawingml/2006/main"/>
           <a:p xmlns:a="http://schemas.openxmlformats.org/drawingml/2006/main">
             <a:pPr>
+              <a:buNone/>
               <a:defRPr sz="1125" b="1">
                 <a:solidFill>
                   <a:srgbClr val="2774C7"/>
@@ -4586,6 +4640,7 @@
           <a:lstStyle xmlns:a="http://schemas.openxmlformats.org/drawingml/2006/main"/>
           <a:p xmlns:a="http://schemas.openxmlformats.org/drawingml/2006/main">
             <a:pPr>
+              <a:buNone/>
               <a:defRPr sz="1125" b="0">
                 <a:solidFill>
                   <a:srgbClr val="667482"/>
@@ -4636,6 +4691,7 @@
           <a:lstStyle xmlns:a="http://schemas.openxmlformats.org/drawingml/2006/main"/>
           <a:p xmlns:a="http://schemas.openxmlformats.org/drawingml/2006/main">
             <a:pPr>
+              <a:buNone/>
               <a:defRPr sz="1125" b="1">
                 <a:solidFill>
                   <a:srgbClr val="2774C7"/>
@@ -4686,6 +4742,7 @@
           <a:lstStyle xmlns:a="http://schemas.openxmlformats.org/drawingml/2006/main"/>
           <a:p xmlns:a="http://schemas.openxmlformats.org/drawingml/2006/main">
             <a:pPr>
+              <a:buNone/>
               <a:defRPr sz="1125" b="0">
                 <a:solidFill>
                   <a:srgbClr val="667482"/>
@@ -4736,6 +4793,7 @@
           <a:lstStyle xmlns:a="http://schemas.openxmlformats.org/drawingml/2006/main"/>
           <a:p xmlns:a="http://schemas.openxmlformats.org/drawingml/2006/main">
             <a:pPr>
+              <a:buNone/>
               <a:defRPr sz="825" b="1">
                 <a:solidFill>
                   <a:srgbClr val="667482"/>
@@ -4786,6 +4844,7 @@
           <a:lstStyle xmlns:a="http://schemas.openxmlformats.org/drawingml/2006/main"/>
           <a:p xmlns:a="http://schemas.openxmlformats.org/drawingml/2006/main">
             <a:pPr>
+              <a:buNone/>
               <a:defRPr sz="825" b="1">
                 <a:solidFill>
                   <a:srgbClr val="667482"/>
@@ -4865,6 +4924,7 @@
           <a:lstStyle xmlns:a="http://schemas.openxmlformats.org/drawingml/2006/main"/>
           <a:p xmlns:a="http://schemas.openxmlformats.org/drawingml/2006/main">
             <a:pPr>
+              <a:buNone/>
               <a:defRPr sz="1125" b="1">
                 <a:solidFill>
                   <a:srgbClr val="2774C7"/>
@@ -4915,14 +4975,15 @@
           <a:lstStyle xmlns:a="http://schemas.openxmlformats.org/drawingml/2006/main"/>
           <a:p xmlns:a="http://schemas.openxmlformats.org/drawingml/2006/main">
             <a:pPr>
-              <a:defRPr sz="3150" b="1">
+              <a:buNone/>
+              <a:defRPr sz="2850" b="1">
                 <a:solidFill>
                   <a:srgbClr val="12263A"/>
                 </a:solidFill>
               </a:defRPr>
             </a:pPr>
             <a:r>
-              <a:rPr sz="3150" b="1">
+              <a:rPr sz="2850" b="1">
                 <a:solidFill>
                   <a:srgbClr val="12263A"/>
                 </a:solidFill>
@@ -4996,6 +5057,7 @@
           <a:lstStyle xmlns:a="http://schemas.openxmlformats.org/drawingml/2006/main"/>
           <a:p xmlns:a="http://schemas.openxmlformats.org/drawingml/2006/main">
             <a:pPr>
+              <a:buNone/>
               <a:defRPr sz="1275" b="0">
                 <a:solidFill>
                   <a:srgbClr val="667482"/>
@@ -5081,6 +5143,7 @@
           <a:lstStyle xmlns:a="http://schemas.openxmlformats.org/drawingml/2006/main"/>
           <a:p xmlns:a="http://schemas.openxmlformats.org/drawingml/2006/main">
             <a:pPr>
+              <a:buNone/>
               <a:defRPr sz="3000" b="1">
                 <a:solidFill>
                   <a:srgbClr val="2774C7"/>
@@ -5131,6 +5194,7 @@
           <a:lstStyle xmlns:a="http://schemas.openxmlformats.org/drawingml/2006/main"/>
           <a:p xmlns:a="http://schemas.openxmlformats.org/drawingml/2006/main">
             <a:pPr>
+              <a:buNone/>
               <a:defRPr sz="1050" b="0">
                 <a:solidFill>
                   <a:srgbClr val="667482"/>
@@ -5216,6 +5280,7 @@
           <a:lstStyle xmlns:a="http://schemas.openxmlformats.org/drawingml/2006/main"/>
           <a:p xmlns:a="http://schemas.openxmlformats.org/drawingml/2006/main">
             <a:pPr>
+              <a:buNone/>
               <a:defRPr sz="3000" b="1">
                 <a:solidFill>
                   <a:srgbClr val="2774C7"/>
@@ -5266,6 +5331,7 @@
           <a:lstStyle xmlns:a="http://schemas.openxmlformats.org/drawingml/2006/main"/>
           <a:p xmlns:a="http://schemas.openxmlformats.org/drawingml/2006/main">
             <a:pPr>
+              <a:buNone/>
               <a:defRPr sz="1050" b="0">
                 <a:solidFill>
                   <a:srgbClr val="667482"/>
@@ -5351,6 +5417,7 @@
           <a:lstStyle xmlns:a="http://schemas.openxmlformats.org/drawingml/2006/main"/>
           <a:p xmlns:a="http://schemas.openxmlformats.org/drawingml/2006/main">
             <a:pPr>
+              <a:buNone/>
               <a:defRPr sz="3000" b="1">
                 <a:solidFill>
                   <a:srgbClr val="2774C7"/>
@@ -5401,6 +5468,7 @@
           <a:lstStyle xmlns:a="http://schemas.openxmlformats.org/drawingml/2006/main"/>
           <a:p xmlns:a="http://schemas.openxmlformats.org/drawingml/2006/main">
             <a:pPr>
+              <a:buNone/>
               <a:defRPr sz="1050" b="0">
                 <a:solidFill>
                   <a:srgbClr val="667482"/>
@@ -5484,6 +5552,7 @@
           <a:lstStyle xmlns:a="http://schemas.openxmlformats.org/drawingml/2006/main"/>
           <a:p xmlns:a="http://schemas.openxmlformats.org/drawingml/2006/main">
             <a:pPr>
+              <a:buNone/>
               <a:defRPr sz="1125" b="1">
                 <a:solidFill>
                   <a:srgbClr val="BFE2D4"/>
@@ -5534,6 +5603,7 @@
           <a:lstStyle xmlns:a="http://schemas.openxmlformats.org/drawingml/2006/main"/>
           <a:p xmlns:a="http://schemas.openxmlformats.org/drawingml/2006/main">
             <a:pPr>
+              <a:buNone/>
               <a:defRPr sz="1725" b="1">
                 <a:solidFill>
                   <a:srgbClr val="FFFFFF"/>
@@ -5584,6 +5654,7 @@
           <a:lstStyle xmlns:a="http://schemas.openxmlformats.org/drawingml/2006/main"/>
           <a:p xmlns:a="http://schemas.openxmlformats.org/drawingml/2006/main">
             <a:pPr>
+              <a:buNone/>
               <a:defRPr sz="1725" b="1">
                 <a:solidFill>
                   <a:srgbClr val="FFFFFF"/>
@@ -5634,6 +5705,7 @@
           <a:lstStyle xmlns:a="http://schemas.openxmlformats.org/drawingml/2006/main"/>
           <a:p xmlns:a="http://schemas.openxmlformats.org/drawingml/2006/main">
             <a:pPr>
+              <a:buNone/>
               <a:defRPr sz="1725" b="1">
                 <a:solidFill>
                   <a:srgbClr val="FFFFFF"/>
@@ -5717,6 +5789,7 @@
           <a:lstStyle xmlns:a="http://schemas.openxmlformats.org/drawingml/2006/main"/>
           <a:p xmlns:a="http://schemas.openxmlformats.org/drawingml/2006/main">
             <a:pPr>
+              <a:buNone/>
               <a:defRPr sz="1125" b="1">
                 <a:solidFill>
                   <a:srgbClr val="2774C7"/>
@@ -5767,6 +5840,7 @@
           <a:lstStyle xmlns:a="http://schemas.openxmlformats.org/drawingml/2006/main"/>
           <a:p xmlns:a="http://schemas.openxmlformats.org/drawingml/2006/main">
             <a:pPr>
+              <a:buNone/>
               <a:defRPr sz="1350" b="0">
                 <a:solidFill>
                   <a:srgbClr val="12263A"/>
@@ -5852,6 +5926,7 @@
           <a:lstStyle xmlns:a="http://schemas.openxmlformats.org/drawingml/2006/main"/>
           <a:p xmlns:a="http://schemas.openxmlformats.org/drawingml/2006/main">
             <a:pPr>
+              <a:buNone/>
               <a:defRPr sz="1050" b="1">
                 <a:solidFill>
                   <a:srgbClr val="E96B4B"/>
@@ -5902,6 +5977,7 @@
           <a:lstStyle xmlns:a="http://schemas.openxmlformats.org/drawingml/2006/main"/>
           <a:p xmlns:a="http://schemas.openxmlformats.org/drawingml/2006/main">
             <a:pPr>
+              <a:buNone/>
               <a:defRPr sz="1275" b="1">
                 <a:solidFill>
                   <a:srgbClr val="12263A"/>
@@ -5952,6 +6028,7 @@
           <a:lstStyle xmlns:a="http://schemas.openxmlformats.org/drawingml/2006/main"/>
           <a:p xmlns:a="http://schemas.openxmlformats.org/drawingml/2006/main">
             <a:pPr>
+              <a:buNone/>
               <a:defRPr sz="825" b="1">
                 <a:solidFill>
                   <a:srgbClr val="667482"/>
@@ -6002,6 +6079,7 @@
           <a:lstStyle xmlns:a="http://schemas.openxmlformats.org/drawingml/2006/main"/>
           <a:p xmlns:a="http://schemas.openxmlformats.org/drawingml/2006/main">
             <a:pPr>
+              <a:buNone/>
               <a:defRPr sz="825" b="1">
                 <a:solidFill>
                   <a:srgbClr val="667482"/>
@@ -6081,6 +6159,7 @@
           <a:lstStyle xmlns:a="http://schemas.openxmlformats.org/drawingml/2006/main"/>
           <a:p xmlns:a="http://schemas.openxmlformats.org/drawingml/2006/main">
             <a:pPr>
+              <a:buNone/>
               <a:defRPr sz="1125" b="1">
                 <a:solidFill>
                   <a:srgbClr val="2774C7"/>
@@ -6131,6 +6210,7 @@
           <a:lstStyle xmlns:a="http://schemas.openxmlformats.org/drawingml/2006/main"/>
           <a:p xmlns:a="http://schemas.openxmlformats.org/drawingml/2006/main">
             <a:pPr>
+              <a:buNone/>
               <a:defRPr sz="3150" b="1">
                 <a:solidFill>
                   <a:srgbClr val="12263A"/>
@@ -6212,6 +6292,7 @@
           <a:lstStyle xmlns:a="http://schemas.openxmlformats.org/drawingml/2006/main"/>
           <a:p xmlns:a="http://schemas.openxmlformats.org/drawingml/2006/main">
             <a:pPr>
+              <a:buNone/>
               <a:defRPr sz="1275" b="0">
                 <a:solidFill>
                   <a:srgbClr val="667482"/>
@@ -6245,7 +6326,7 @@
         </p:nvSpPr>
         <p:spPr>
           <a:xfrm xmlns:a="http://schemas.openxmlformats.org/drawingml/2006/main">
-            <a:off x="3295650" y="2209800"/>
+            <a:off x="3295650" y="2571750"/>
             <a:ext cx="571500" cy="228600"/>
           </a:xfrm>
           <a:prstGeom xmlns:a="http://schemas.openxmlformats.org/drawingml/2006/main" prst="rect">
@@ -6262,6 +6343,7 @@
           <a:lstStyle xmlns:a="http://schemas.openxmlformats.org/drawingml/2006/main"/>
           <a:p xmlns:a="http://schemas.openxmlformats.org/drawingml/2006/main">
             <a:pPr>
+              <a:buNone/>
               <a:defRPr sz="975" b="1">
                 <a:solidFill>
                   <a:srgbClr val="667482"/>
@@ -6295,8 +6377,8 @@
         </p:nvSpPr>
         <p:spPr>
           <a:xfrm xmlns:a="http://schemas.openxmlformats.org/drawingml/2006/main">
-            <a:off x="3295650" y="2495550"/>
-            <a:ext cx="9525" cy="2724150"/>
+            <a:off x="3295650" y="2819400"/>
+            <a:ext cx="9525" cy="2057400"/>
           </a:xfrm>
           <a:prstGeom xmlns:a="http://schemas.openxmlformats.org/drawingml/2006/main" prst="rect">
             <a:avLst/>
@@ -6326,7 +6408,7 @@
         </p:nvSpPr>
         <p:spPr>
           <a:xfrm xmlns:a="http://schemas.openxmlformats.org/drawingml/2006/main">
-            <a:off x="4248150" y="2209800"/>
+            <a:off x="4248150" y="2571750"/>
             <a:ext cx="571500" cy="228600"/>
           </a:xfrm>
           <a:prstGeom xmlns:a="http://schemas.openxmlformats.org/drawingml/2006/main" prst="rect">
@@ -6343,6 +6425,7 @@
           <a:lstStyle xmlns:a="http://schemas.openxmlformats.org/drawingml/2006/main"/>
           <a:p xmlns:a="http://schemas.openxmlformats.org/drawingml/2006/main">
             <a:pPr>
+              <a:buNone/>
               <a:defRPr sz="975" b="1">
                 <a:solidFill>
                   <a:srgbClr val="667482"/>
@@ -6376,8 +6459,8 @@
         </p:nvSpPr>
         <p:spPr>
           <a:xfrm xmlns:a="http://schemas.openxmlformats.org/drawingml/2006/main">
-            <a:off x="4248150" y="2495550"/>
-            <a:ext cx="9525" cy="2724150"/>
+            <a:off x="4248150" y="2819400"/>
+            <a:ext cx="9525" cy="2057400"/>
           </a:xfrm>
           <a:prstGeom xmlns:a="http://schemas.openxmlformats.org/drawingml/2006/main" prst="rect">
             <a:avLst/>
@@ -6407,7 +6490,7 @@
         </p:nvSpPr>
         <p:spPr>
           <a:xfrm xmlns:a="http://schemas.openxmlformats.org/drawingml/2006/main">
-            <a:off x="5200650" y="2209800"/>
+            <a:off x="5200650" y="2571750"/>
             <a:ext cx="571500" cy="228600"/>
           </a:xfrm>
           <a:prstGeom xmlns:a="http://schemas.openxmlformats.org/drawingml/2006/main" prst="rect">
@@ -6424,6 +6507,7 @@
           <a:lstStyle xmlns:a="http://schemas.openxmlformats.org/drawingml/2006/main"/>
           <a:p xmlns:a="http://schemas.openxmlformats.org/drawingml/2006/main">
             <a:pPr>
+              <a:buNone/>
               <a:defRPr sz="975" b="1">
                 <a:solidFill>
                   <a:srgbClr val="667482"/>
@@ -6457,8 +6541,8 @@
         </p:nvSpPr>
         <p:spPr>
           <a:xfrm xmlns:a="http://schemas.openxmlformats.org/drawingml/2006/main">
-            <a:off x="5200650" y="2495550"/>
-            <a:ext cx="9525" cy="2724150"/>
+            <a:off x="5200650" y="2819400"/>
+            <a:ext cx="9525" cy="2057400"/>
           </a:xfrm>
           <a:prstGeom xmlns:a="http://schemas.openxmlformats.org/drawingml/2006/main" prst="rect">
             <a:avLst/>
@@ -6488,7 +6572,7 @@
         </p:nvSpPr>
         <p:spPr>
           <a:xfrm xmlns:a="http://schemas.openxmlformats.org/drawingml/2006/main">
-            <a:off x="6153150" y="2209800"/>
+            <a:off x="6153150" y="2571750"/>
             <a:ext cx="571500" cy="228600"/>
           </a:xfrm>
           <a:prstGeom xmlns:a="http://schemas.openxmlformats.org/drawingml/2006/main" prst="rect">
@@ -6505,6 +6589,7 @@
           <a:lstStyle xmlns:a="http://schemas.openxmlformats.org/drawingml/2006/main"/>
           <a:p xmlns:a="http://schemas.openxmlformats.org/drawingml/2006/main">
             <a:pPr>
+              <a:buNone/>
               <a:defRPr sz="975" b="1">
                 <a:solidFill>
                   <a:srgbClr val="667482"/>
@@ -6538,8 +6623,8 @@
         </p:nvSpPr>
         <p:spPr>
           <a:xfrm xmlns:a="http://schemas.openxmlformats.org/drawingml/2006/main">
-            <a:off x="6153150" y="2495550"/>
-            <a:ext cx="9525" cy="2724150"/>
+            <a:off x="6153150" y="2819400"/>
+            <a:ext cx="9525" cy="2057400"/>
           </a:xfrm>
           <a:prstGeom xmlns:a="http://schemas.openxmlformats.org/drawingml/2006/main" prst="rect">
             <a:avLst/>
@@ -6569,7 +6654,7 @@
         </p:nvSpPr>
         <p:spPr>
           <a:xfrm xmlns:a="http://schemas.openxmlformats.org/drawingml/2006/main">
-            <a:off x="7105650" y="2209800"/>
+            <a:off x="7105650" y="2571750"/>
             <a:ext cx="571500" cy="228600"/>
           </a:xfrm>
           <a:prstGeom xmlns:a="http://schemas.openxmlformats.org/drawingml/2006/main" prst="rect">
@@ -6586,6 +6671,7 @@
           <a:lstStyle xmlns:a="http://schemas.openxmlformats.org/drawingml/2006/main"/>
           <a:p xmlns:a="http://schemas.openxmlformats.org/drawingml/2006/main">
             <a:pPr>
+              <a:buNone/>
               <a:defRPr sz="975" b="1">
                 <a:solidFill>
                   <a:srgbClr val="667482"/>
@@ -6619,8 +6705,8 @@
         </p:nvSpPr>
         <p:spPr>
           <a:xfrm xmlns:a="http://schemas.openxmlformats.org/drawingml/2006/main">
-            <a:off x="7105650" y="2495550"/>
-            <a:ext cx="9525" cy="2724150"/>
+            <a:off x="7105650" y="2819400"/>
+            <a:ext cx="9525" cy="2057400"/>
           </a:xfrm>
           <a:prstGeom xmlns:a="http://schemas.openxmlformats.org/drawingml/2006/main" prst="rect">
             <a:avLst/>
@@ -6650,7 +6736,7 @@
         </p:nvSpPr>
         <p:spPr>
           <a:xfrm xmlns:a="http://schemas.openxmlformats.org/drawingml/2006/main">
-            <a:off x="8058150" y="2209800"/>
+            <a:off x="8058150" y="2571750"/>
             <a:ext cx="571500" cy="228600"/>
           </a:xfrm>
           <a:prstGeom xmlns:a="http://schemas.openxmlformats.org/drawingml/2006/main" prst="rect">
@@ -6667,6 +6753,7 @@
           <a:lstStyle xmlns:a="http://schemas.openxmlformats.org/drawingml/2006/main"/>
           <a:p xmlns:a="http://schemas.openxmlformats.org/drawingml/2006/main">
             <a:pPr>
+              <a:buNone/>
               <a:defRPr sz="975" b="1">
                 <a:solidFill>
                   <a:srgbClr val="667482"/>
@@ -6700,8 +6787,8 @@
         </p:nvSpPr>
         <p:spPr>
           <a:xfrm xmlns:a="http://schemas.openxmlformats.org/drawingml/2006/main">
-            <a:off x="8058150" y="2495550"/>
-            <a:ext cx="9525" cy="2724150"/>
+            <a:off x="8058150" y="2819400"/>
+            <a:ext cx="9525" cy="2057400"/>
           </a:xfrm>
           <a:prstGeom xmlns:a="http://schemas.openxmlformats.org/drawingml/2006/main" prst="rect">
             <a:avLst/>
@@ -6731,7 +6818,7 @@
         </p:nvSpPr>
         <p:spPr>
           <a:xfrm xmlns:a="http://schemas.openxmlformats.org/drawingml/2006/main">
-            <a:off x="9010650" y="2209800"/>
+            <a:off x="9010650" y="2571750"/>
             <a:ext cx="571500" cy="228600"/>
           </a:xfrm>
           <a:prstGeom xmlns:a="http://schemas.openxmlformats.org/drawingml/2006/main" prst="rect">
@@ -6748,6 +6835,7 @@
           <a:lstStyle xmlns:a="http://schemas.openxmlformats.org/drawingml/2006/main"/>
           <a:p xmlns:a="http://schemas.openxmlformats.org/drawingml/2006/main">
             <a:pPr>
+              <a:buNone/>
               <a:defRPr sz="975" b="1">
                 <a:solidFill>
                   <a:srgbClr val="667482"/>
@@ -6781,8 +6869,8 @@
         </p:nvSpPr>
         <p:spPr>
           <a:xfrm xmlns:a="http://schemas.openxmlformats.org/drawingml/2006/main">
-            <a:off x="9010650" y="2495550"/>
-            <a:ext cx="9525" cy="2724150"/>
+            <a:off x="9010650" y="2819400"/>
+            <a:ext cx="9525" cy="2057400"/>
           </a:xfrm>
           <a:prstGeom xmlns:a="http://schemas.openxmlformats.org/drawingml/2006/main" prst="rect">
             <a:avLst/>
@@ -6812,7 +6900,7 @@
         </p:nvSpPr>
         <p:spPr>
           <a:xfrm xmlns:a="http://schemas.openxmlformats.org/drawingml/2006/main">
-            <a:off x="9963150" y="2209800"/>
+            <a:off x="9963150" y="2571750"/>
             <a:ext cx="571500" cy="228600"/>
           </a:xfrm>
           <a:prstGeom xmlns:a="http://schemas.openxmlformats.org/drawingml/2006/main" prst="rect">
@@ -6829,6 +6917,7 @@
           <a:lstStyle xmlns:a="http://schemas.openxmlformats.org/drawingml/2006/main"/>
           <a:p xmlns:a="http://schemas.openxmlformats.org/drawingml/2006/main">
             <a:pPr>
+              <a:buNone/>
               <a:defRPr sz="975" b="1">
                 <a:solidFill>
                   <a:srgbClr val="667482"/>
@@ -6862,8 +6951,8 @@
         </p:nvSpPr>
         <p:spPr>
           <a:xfrm xmlns:a="http://schemas.openxmlformats.org/drawingml/2006/main">
-            <a:off x="9963150" y="2495550"/>
-            <a:ext cx="9525" cy="2724150"/>
+            <a:off x="9963150" y="2819400"/>
+            <a:ext cx="9525" cy="2057400"/>
           </a:xfrm>
           <a:prstGeom xmlns:a="http://schemas.openxmlformats.org/drawingml/2006/main" prst="rect">
             <a:avLst/>
@@ -6893,7 +6982,7 @@
         </p:nvSpPr>
         <p:spPr>
           <a:xfrm xmlns:a="http://schemas.openxmlformats.org/drawingml/2006/main">
-            <a:off x="552450" y="2705100"/>
+            <a:off x="552450" y="3028950"/>
             <a:ext cx="2381250" cy="266700"/>
           </a:xfrm>
           <a:prstGeom xmlns:a="http://schemas.openxmlformats.org/drawingml/2006/main" prst="rect">
@@ -6910,6 +6999,7 @@
           <a:lstStyle xmlns:a="http://schemas.openxmlformats.org/drawingml/2006/main"/>
           <a:p xmlns:a="http://schemas.openxmlformats.org/drawingml/2006/main">
             <a:pPr>
+              <a:buNone/>
               <a:defRPr sz="1275" b="1">
                 <a:solidFill>
                   <a:srgbClr val="12263A"/>
@@ -6943,8 +7033,8 @@
         </p:nvSpPr>
         <p:spPr>
           <a:xfrm xmlns:a="http://schemas.openxmlformats.org/drawingml/2006/main">
-            <a:off x="3352800" y="2647950"/>
-            <a:ext cx="819150" cy="400050"/>
+            <a:off x="3352800" y="2971800"/>
+            <a:ext cx="819150" cy="323850"/>
           </a:xfrm>
           <a:prstGeom xmlns:a="http://schemas.openxmlformats.org/drawingml/2006/main" prst="roundRect">
             <a:avLst>
@@ -6976,7 +7066,7 @@
         </p:nvSpPr>
         <p:spPr>
           <a:xfrm xmlns:a="http://schemas.openxmlformats.org/drawingml/2006/main">
-            <a:off x="552450" y="3333750"/>
+            <a:off x="552450" y="3505200"/>
             <a:ext cx="2381250" cy="266700"/>
           </a:xfrm>
           <a:prstGeom xmlns:a="http://schemas.openxmlformats.org/drawingml/2006/main" prst="rect">
@@ -6993,6 +7083,7 @@
           <a:lstStyle xmlns:a="http://schemas.openxmlformats.org/drawingml/2006/main"/>
           <a:p xmlns:a="http://schemas.openxmlformats.org/drawingml/2006/main">
             <a:pPr>
+              <a:buNone/>
               <a:defRPr sz="1275" b="1">
                 <a:solidFill>
                   <a:srgbClr val="12263A"/>
@@ -7026,8 +7117,8 @@
         </p:nvSpPr>
         <p:spPr>
           <a:xfrm xmlns:a="http://schemas.openxmlformats.org/drawingml/2006/main">
-            <a:off x="4305300" y="3276600"/>
-            <a:ext cx="3676650" cy="400050"/>
+            <a:off x="4305300" y="3448050"/>
+            <a:ext cx="3676650" cy="323850"/>
           </a:xfrm>
           <a:prstGeom xmlns:a="http://schemas.openxmlformats.org/drawingml/2006/main" prst="roundRect">
             <a:avLst>
@@ -7059,7 +7150,7 @@
         </p:nvSpPr>
         <p:spPr>
           <a:xfrm xmlns:a="http://schemas.openxmlformats.org/drawingml/2006/main">
-            <a:off x="552450" y="3962400"/>
+            <a:off x="552450" y="3981450"/>
             <a:ext cx="2381250" cy="266700"/>
           </a:xfrm>
           <a:prstGeom xmlns:a="http://schemas.openxmlformats.org/drawingml/2006/main" prst="rect">
@@ -7076,6 +7167,7 @@
           <a:lstStyle xmlns:a="http://schemas.openxmlformats.org/drawingml/2006/main"/>
           <a:p xmlns:a="http://schemas.openxmlformats.org/drawingml/2006/main">
             <a:pPr>
+              <a:buNone/>
               <a:defRPr sz="1275" b="1">
                 <a:solidFill>
                   <a:srgbClr val="12263A"/>
@@ -7109,8 +7201,8 @@
         </p:nvSpPr>
         <p:spPr>
           <a:xfrm xmlns:a="http://schemas.openxmlformats.org/drawingml/2006/main">
-            <a:off x="8115300" y="3905250"/>
-            <a:ext cx="1771650" cy="400050"/>
+            <a:off x="8115300" y="3924300"/>
+            <a:ext cx="1771650" cy="323850"/>
           </a:xfrm>
           <a:prstGeom xmlns:a="http://schemas.openxmlformats.org/drawingml/2006/main" prst="roundRect">
             <a:avLst>
@@ -7142,7 +7234,7 @@
         </p:nvSpPr>
         <p:spPr>
           <a:xfrm xmlns:a="http://schemas.openxmlformats.org/drawingml/2006/main">
-            <a:off x="552450" y="4591050"/>
+            <a:off x="552450" y="4457700"/>
             <a:ext cx="2381250" cy="266700"/>
           </a:xfrm>
           <a:prstGeom xmlns:a="http://schemas.openxmlformats.org/drawingml/2006/main" prst="rect">
@@ -7159,6 +7251,7 @@
           <a:lstStyle xmlns:a="http://schemas.openxmlformats.org/drawingml/2006/main"/>
           <a:p xmlns:a="http://schemas.openxmlformats.org/drawingml/2006/main">
             <a:pPr>
+              <a:buNone/>
               <a:defRPr sz="1275" b="1">
                 <a:solidFill>
                   <a:srgbClr val="12263A"/>
@@ -7192,8 +7285,8 @@
         </p:nvSpPr>
         <p:spPr>
           <a:xfrm xmlns:a="http://schemas.openxmlformats.org/drawingml/2006/main">
-            <a:off x="10020300" y="4533900"/>
-            <a:ext cx="819150" cy="400050"/>
+            <a:off x="10020300" y="4400550"/>
+            <a:ext cx="819150" cy="323850"/>
           </a:xfrm>
           <a:prstGeom xmlns:a="http://schemas.openxmlformats.org/drawingml/2006/main" prst="roundRect">
             <a:avLst>
@@ -7225,8 +7318,8 @@
         </p:nvSpPr>
         <p:spPr>
           <a:xfrm xmlns:a="http://schemas.openxmlformats.org/drawingml/2006/main">
-            <a:off x="552450" y="5448300"/>
-            <a:ext cx="11087100" cy="609600"/>
+            <a:off x="552450" y="5105400"/>
+            <a:ext cx="11087100" cy="800100"/>
           </a:xfrm>
           <a:prstGeom xmlns:a="http://schemas.openxmlformats.org/drawingml/2006/main" prst="roundRect">
             <a:avLst>
@@ -7258,7 +7351,7 @@
         </p:nvSpPr>
         <p:spPr>
           <a:xfrm xmlns:a="http://schemas.openxmlformats.org/drawingml/2006/main">
-            <a:off x="800100" y="5638800"/>
+            <a:off x="800100" y="5362575"/>
             <a:ext cx="1619250" cy="228600"/>
           </a:xfrm>
           <a:prstGeom xmlns:a="http://schemas.openxmlformats.org/drawingml/2006/main" prst="rect">
@@ -7275,6 +7368,7 @@
           <a:lstStyle xmlns:a="http://schemas.openxmlformats.org/drawingml/2006/main"/>
           <a:p xmlns:a="http://schemas.openxmlformats.org/drawingml/2006/main">
             <a:pPr>
+              <a:buNone/>
               <a:defRPr sz="1050" b="1">
                 <a:solidFill>
                   <a:srgbClr val="BFE2D4"/>
@@ -7308,7 +7402,7 @@
         </p:nvSpPr>
         <p:spPr>
           <a:xfrm xmlns:a="http://schemas.openxmlformats.org/drawingml/2006/main">
-            <a:off x="2476500" y="5619750"/>
+            <a:off x="2476500" y="5343525"/>
             <a:ext cx="8572500" cy="266700"/>
           </a:xfrm>
           <a:prstGeom xmlns:a="http://schemas.openxmlformats.org/drawingml/2006/main" prst="rect">
@@ -7325,6 +7419,7 @@
           <a:lstStyle xmlns:a="http://schemas.openxmlformats.org/drawingml/2006/main"/>
           <a:p xmlns:a="http://schemas.openxmlformats.org/drawingml/2006/main">
             <a:pPr>
+              <a:buNone/>
               <a:defRPr sz="1425" b="1">
                 <a:solidFill>
                   <a:srgbClr val="FFFFFF"/>
@@ -7375,6 +7470,7 @@
           <a:lstStyle xmlns:a="http://schemas.openxmlformats.org/drawingml/2006/main"/>
           <a:p xmlns:a="http://schemas.openxmlformats.org/drawingml/2006/main">
             <a:pPr>
+              <a:buNone/>
               <a:defRPr sz="825" b="1">
                 <a:solidFill>
                   <a:srgbClr val="667482"/>
@@ -7425,6 +7521,7 @@
           <a:lstStyle xmlns:a="http://schemas.openxmlformats.org/drawingml/2006/main"/>
           <a:p xmlns:a="http://schemas.openxmlformats.org/drawingml/2006/main">
             <a:pPr>
+              <a:buNone/>
               <a:defRPr sz="825" b="1">
                 <a:solidFill>
                   <a:srgbClr val="667482"/>
@@ -7438,6 +7535,143 @@
                 </a:solidFill>
               </a:rPr>
               <a:t>06</a:t>
+            </a:r>
+          </a:p>
+        </p:txBody>
+      </p:sp>
+      <p:sp>
+        <p:nvSpPr>
+          <p:cNvPr id="35" name="framework-strip">
+            <a:extLst xmlns:a="http://schemas.openxmlformats.org/drawingml/2006/main">
+              <a:ext uri="{FF2B5EF4-FFF2-40B4-BE49-F238E27FC236}">
+                <a16:creationId xmlns:a16="http://schemas.microsoft.com/office/drawing/2014/main" id="{7242F7D8-4EBD-454B-9A51-9E0794F7A1D7}"/>
+              </a:ext>
+            </a:extLst>
+          </p:cNvPr>
+          <p:cNvSpPr>
+            <a:spLocks xmlns:a="http://schemas.openxmlformats.org/drawingml/2006/main" noGrp="1"/>
+          </p:cNvSpPr>
+          <p:nvPr/>
+        </p:nvSpPr>
+        <p:spPr>
+          <a:xfrm xmlns:a="http://schemas.openxmlformats.org/drawingml/2006/main">
+            <a:off x="552450" y="2076450"/>
+            <a:ext cx="11087100" cy="400050"/>
+          </a:xfrm>
+          <a:prstGeom xmlns:a="http://schemas.openxmlformats.org/drawingml/2006/main" prst="roundRect">
+            <a:avLst>
+              <a:gd name="adj" fmla="val 28571"/>
+            </a:avLst>
+          </a:prstGeom>
+          <a:solidFill xmlns:a="http://schemas.openxmlformats.org/drawingml/2006/main">
+            <a:srgbClr val="EAF2FA"/>
+          </a:solidFill>
+          <a:ln xmlns:a="http://schemas.openxmlformats.org/drawingml/2006/main" w="9525">
+            <a:solidFill>
+              <a:srgbClr val="CBD5DF"/>
+            </a:solidFill>
+            <a:prstDash val="solid"/>
+          </a:ln>
+        </p:spPr>
+      </p:sp>
+      <p:sp>
+        <p:nvSpPr>
+          <p:cNvPr id="36" name="framework-label">
+            <a:extLst xmlns:a="http://schemas.openxmlformats.org/drawingml/2006/main">
+              <a:ext uri="{FF2B5EF4-FFF2-40B4-BE49-F238E27FC236}">
+                <a16:creationId xmlns:a16="http://schemas.microsoft.com/office/drawing/2014/main" id="{5401567E-948B-45B3-9D7F-B8C0798DAC51}"/>
+              </a:ext>
+            </a:extLst>
+          </p:cNvPr>
+          <p:cNvSpPr>
+            <a:spLocks xmlns:a="http://schemas.openxmlformats.org/drawingml/2006/main" noGrp="1"/>
+          </p:cNvSpPr>
+          <p:nvPr/>
+        </p:nvSpPr>
+        <p:spPr>
+          <a:xfrm xmlns:a="http://schemas.openxmlformats.org/drawingml/2006/main">
+            <a:off x="781050" y="2152650"/>
+            <a:ext cx="1428750" cy="247650"/>
+          </a:xfrm>
+          <a:prstGeom xmlns:a="http://schemas.openxmlformats.org/drawingml/2006/main" prst="rect">
+            <a:avLst/>
+          </a:prstGeom>
+          <a:noFill xmlns:a="http://schemas.openxmlformats.org/drawingml/2006/main"/>
+          <a:ln xmlns:a="http://schemas.openxmlformats.org/drawingml/2006/main" w="0">
+            <a:noFill/>
+            <a:prstDash val="solid"/>
+          </a:ln>
+        </p:spPr>
+        <p:txBody>
+          <a:bodyPr xmlns:a="http://schemas.openxmlformats.org/drawingml/2006/main"/>
+          <a:lstStyle xmlns:a="http://schemas.openxmlformats.org/drawingml/2006/main"/>
+          <a:p xmlns:a="http://schemas.openxmlformats.org/drawingml/2006/main">
+            <a:pPr>
+              <a:buNone/>
+              <a:defRPr sz="1200" b="1">
+                <a:solidFill>
+                  <a:srgbClr val="2774C7"/>
+                </a:solidFill>
+              </a:defRPr>
+            </a:pPr>
+            <a:r>
+              <a:rPr sz="1200" b="1">
+                <a:solidFill>
+                  <a:srgbClr val="2774C7"/>
+                </a:solidFill>
+              </a:rPr>
+              <a:t>FRAMEWORKS</a:t>
+            </a:r>
+          </a:p>
+        </p:txBody>
+      </p:sp>
+      <p:sp>
+        <p:nvSpPr>
+          <p:cNvPr id="37" name="framework-list">
+            <a:extLst xmlns:a="http://schemas.openxmlformats.org/drawingml/2006/main">
+              <a:ext uri="{FF2B5EF4-FFF2-40B4-BE49-F238E27FC236}">
+                <a16:creationId xmlns:a16="http://schemas.microsoft.com/office/drawing/2014/main" id="{EB13FE2A-9DFE-4004-8720-6AC345E49E40}"/>
+              </a:ext>
+            </a:extLst>
+          </p:cNvPr>
+          <p:cNvSpPr>
+            <a:spLocks xmlns:a="http://schemas.openxmlformats.org/drawingml/2006/main" noGrp="1"/>
+          </p:cNvSpPr>
+          <p:nvPr/>
+        </p:nvSpPr>
+        <p:spPr>
+          <a:xfrm xmlns:a="http://schemas.openxmlformats.org/drawingml/2006/main">
+            <a:off x="2228850" y="2143125"/>
+            <a:ext cx="9048750" cy="266700"/>
+          </a:xfrm>
+          <a:prstGeom xmlns:a="http://schemas.openxmlformats.org/drawingml/2006/main" prst="rect">
+            <a:avLst/>
+          </a:prstGeom>
+          <a:noFill xmlns:a="http://schemas.openxmlformats.org/drawingml/2006/main"/>
+          <a:ln xmlns:a="http://schemas.openxmlformats.org/drawingml/2006/main" w="0">
+            <a:noFill/>
+            <a:prstDash val="solid"/>
+          </a:ln>
+        </p:spPr>
+        <p:txBody>
+          <a:bodyPr xmlns:a="http://schemas.openxmlformats.org/drawingml/2006/main"/>
+          <a:lstStyle xmlns:a="http://schemas.openxmlformats.org/drawingml/2006/main"/>
+          <a:p xmlns:a="http://schemas.openxmlformats.org/drawingml/2006/main">
+            <a:pPr>
+              <a:buNone/>
+              <a:defRPr sz="1200" b="1">
+                <a:solidFill>
+                  <a:srgbClr val="12263A"/>
+                </a:solidFill>
+              </a:defRPr>
+            </a:pPr>
+            <a:r>
+              <a:rPr sz="1200" b="1">
+                <a:solidFill>
+                  <a:srgbClr val="12263A"/>
+                </a:solidFill>
+              </a:rPr>
+              <a:t>React  ·  Express  ·  PostgreSQL + Prisma  ·  Vitest + Playwright  ·  Docker + GitHub Actions</a:t>
             </a:r>
           </a:p>
         </p:txBody>

</xml_diff>